<commit_message>
Keep one submission deck and link the published demo.
The eight-slide deck now includes the Interra demo URL, and the earlier twelve-slide PowerPoint is removed.

Co-authored-by: Maitri Shah <Maitri-shah29@users.noreply.github.com>
</commit_message>
<xml_diff>
--- a/docs/Interra_Theme05_submission.pptx
+++ b/docs/Interra_Theme05_submission.pptx
@@ -481,7 +481,7 @@
               <a:buNone/>
             </a:pPr>
             <a:r>
-              <a:t>Sources: supplied Theme05_Participant_Guide_UPDATED_FBD.docx (maximum eight slides); docs/results/interra_elevenlabs_pass_rate_report.json; docs/results/interra_elevenlabs_evaluation_report.json; docs/results/run-manifest.json; docs/ARCHITECTURE.md. The latest source is awaiting a new score. Live extension demonstration is pending.</a:t>
+              <a:t>Sources: supplied Theme05_Participant_Guide_UPDATED_FBD.docx (maximum eight slides); docs/results/interra_elevenlabs_pass_rate_report.json; docs/results/interra_elevenlabs_evaluation_report.json; docs/results/run-manifest.json; docs/ARCHITECTURE.md. The latest source is awaiting a new score. Demo: https://cursor.com/artifacts/v/art-65efdeb4-9b6f-4416-839a-875b82833f5a</a:t>
             </a:r>
             <a:endParaRPr/>
           </a:p>
@@ -561,7 +561,7 @@
               <a:buNone/>
             </a:pPr>
             <a:r>
-              <a:t>Sources: supplied Theme05_Participant_Guide_UPDATED_FBD.docx (maximum eight slides); docs/results/interra_elevenlabs_pass_rate_report.json; docs/results/interra_elevenlabs_evaluation_report.json; docs/results/run-manifest.json; docs/ARCHITECTURE.md. The latest source is awaiting a new score. Live extension demonstration is pending.</a:t>
+              <a:t>Sources: supplied Theme05_Participant_Guide_UPDATED_FBD.docx (maximum eight slides); docs/results/interra_elevenlabs_pass_rate_report.json; docs/results/interra_elevenlabs_evaluation_report.json; docs/results/run-manifest.json; docs/ARCHITECTURE.md. The latest source is awaiting a new score. Demo: https://cursor.com/artifacts/v/art-65efdeb4-9b6f-4416-839a-875b82833f5a</a:t>
             </a:r>
             <a:endParaRPr/>
           </a:p>
@@ -641,7 +641,7 @@
               <a:buNone/>
             </a:pPr>
             <a:r>
-              <a:t>Sources: supplied Theme05_Participant_Guide_UPDATED_FBD.docx (maximum eight slides); docs/results/interra_elevenlabs_pass_rate_report.json; docs/results/interra_elevenlabs_evaluation_report.json; docs/results/run-manifest.json; docs/ARCHITECTURE.md. The latest source is awaiting a new score. Live extension demonstration is pending.</a:t>
+              <a:t>Sources: supplied Theme05_Participant_Guide_UPDATED_FBD.docx (maximum eight slides); docs/results/interra_elevenlabs_pass_rate_report.json; docs/results/interra_elevenlabs_evaluation_report.json; docs/results/run-manifest.json; docs/ARCHITECTURE.md. The latest source is awaiting a new score. Demo: https://cursor.com/artifacts/v/art-65efdeb4-9b6f-4416-839a-875b82833f5a</a:t>
             </a:r>
             <a:endParaRPr/>
           </a:p>
@@ -721,7 +721,7 @@
               <a:buNone/>
             </a:pPr>
             <a:r>
-              <a:t>Sources: supplied Theme05_Participant_Guide_UPDATED_FBD.docx (maximum eight slides); docs/results/interra_elevenlabs_pass_rate_report.json; docs/results/interra_elevenlabs_evaluation_report.json; docs/results/run-manifest.json; docs/ARCHITECTURE.md. The latest source is awaiting a new score. Live extension demonstration is pending.</a:t>
+              <a:t>Sources: supplied Theme05_Participant_Guide_UPDATED_FBD.docx (maximum eight slides); docs/results/interra_elevenlabs_pass_rate_report.json; docs/results/interra_elevenlabs_evaluation_report.json; docs/results/run-manifest.json; docs/ARCHITECTURE.md. The latest source is awaiting a new score. Demo: https://cursor.com/artifacts/v/art-65efdeb4-9b6f-4416-839a-875b82833f5a</a:t>
             </a:r>
             <a:endParaRPr/>
           </a:p>
@@ -801,7 +801,7 @@
               <a:buNone/>
             </a:pPr>
             <a:r>
-              <a:t>Sources: supplied Theme05_Participant_Guide_UPDATED_FBD.docx (maximum eight slides); docs/results/interra_elevenlabs_pass_rate_report.json; docs/results/interra_elevenlabs_evaluation_report.json; docs/results/run-manifest.json; docs/ARCHITECTURE.md. The latest source is awaiting a new score. Live extension demonstration is pending.</a:t>
+              <a:t>Sources: supplied Theme05_Participant_Guide_UPDATED_FBD.docx (maximum eight slides); docs/results/interra_elevenlabs_pass_rate_report.json; docs/results/interra_elevenlabs_evaluation_report.json; docs/results/run-manifest.json; docs/ARCHITECTURE.md. The latest source is awaiting a new score. Demo: https://cursor.com/artifacts/v/art-65efdeb4-9b6f-4416-839a-875b82833f5a</a:t>
             </a:r>
             <a:endParaRPr/>
           </a:p>
@@ -881,7 +881,7 @@
               <a:buNone/>
             </a:pPr>
             <a:r>
-              <a:t>Sources: supplied Theme05_Participant_Guide_UPDATED_FBD.docx (maximum eight slides); docs/results/interra_elevenlabs_pass_rate_report.json; docs/results/interra_elevenlabs_evaluation_report.json; docs/results/run-manifest.json; docs/ARCHITECTURE.md. The latest source is awaiting a new score. Live extension demonstration is pending.</a:t>
+              <a:t>Sources: supplied Theme05_Participant_Guide_UPDATED_FBD.docx (maximum eight slides); docs/results/interra_elevenlabs_pass_rate_report.json; docs/results/interra_elevenlabs_evaluation_report.json; docs/results/run-manifest.json; docs/ARCHITECTURE.md. The latest source is awaiting a new score. Demo: https://cursor.com/artifacts/v/art-65efdeb4-9b6f-4416-839a-875b82833f5a</a:t>
             </a:r>
             <a:endParaRPr/>
           </a:p>
@@ -961,7 +961,7 @@
               <a:buNone/>
             </a:pPr>
             <a:r>
-              <a:t>Sources: supplied Theme05_Participant_Guide_UPDATED_FBD.docx (maximum eight slides); docs/results/interra_elevenlabs_pass_rate_report.json; docs/results/interra_elevenlabs_evaluation_report.json; docs/results/run-manifest.json; docs/ARCHITECTURE.md. The latest source is awaiting a new score. Live extension demonstration is pending.</a:t>
+              <a:t>Sources: supplied Theme05_Participant_Guide_UPDATED_FBD.docx (maximum eight slides); docs/results/interra_elevenlabs_pass_rate_report.json; docs/results/interra_elevenlabs_evaluation_report.json; docs/results/run-manifest.json; docs/ARCHITECTURE.md. The latest source is awaiting a new score. Demo: https://cursor.com/artifacts/v/art-65efdeb4-9b6f-4416-839a-875b82833f5a</a:t>
             </a:r>
             <a:endParaRPr/>
           </a:p>
@@ -1041,7 +1041,7 @@
               <a:buNone/>
             </a:pPr>
             <a:r>
-              <a:t>Sources: supplied Theme05_Participant_Guide_UPDATED_FBD.docx (maximum eight slides); docs/results/interra_elevenlabs_pass_rate_report.json; docs/results/interra_elevenlabs_evaluation_report.json; docs/results/run-manifest.json; docs/ARCHITECTURE.md. The latest source is awaiting a new score. Live extension demonstration is pending.</a:t>
+              <a:t>Sources: supplied Theme05_Participant_Guide_UPDATED_FBD.docx (maximum eight slides); docs/results/interra_elevenlabs_pass_rate_report.json; docs/results/interra_elevenlabs_evaluation_report.json; docs/results/run-manifest.json; docs/ARCHITECTURE.md. The latest source is awaiting a new score. Demo: https://cursor.com/artifacts/v/art-65efdeb4-9b6f-4416-839a-875b82833f5a</a:t>
             </a:r>
             <a:endParaRPr/>
           </a:p>
@@ -13201,7 +13201,7 @@
                 <a:ea typeface="Calibri"/>
                 <a:cs typeface="Calibri"/>
               </a:rPr>
-              <a:t>The required demo will show a real benchmark interruption or self-correction, with the resulting tool call and timestamps.</a:t>
+              <a:t>Demo: https://cursor.com/artifacts/v/art-65efdeb4-9b6f-4416-839a-875b82833f5a</a:t>
             </a:r>
           </a:p>
           <a:p xmlns:a="http://schemas.openxmlformats.org/drawingml/2006/main">
@@ -13294,7 +13294,7 @@
                 <a:ea typeface="Calibri"/>
                 <a:cs typeface="Calibri"/>
               </a:rPr>
-              <a:t>A live three-to-five-minute recording is pending.</a:t>
+              <a:t>The recording discards the late Delhi result and finishes with destination Mumbai.</a:t>
             </a:r>
           </a:p>
         </p:txBody>
@@ -13538,7 +13538,7 @@
                 <a:ea typeface="Calibri"/>
                 <a:cs typeface="Calibri"/>
               </a:rPr>
-              <a:t>The use case counts when a 3 to 5 minute video shows this session working, after a benchmark interruption.</a:t>
+              <a:t>Demo: https://cursor.com/artifacts/v/art-65efdeb4-9b6f-4416-839a-875b82833f5a</a:t>
             </a:r>
           </a:p>
         </p:txBody>
@@ -14075,7 +14075,7 @@
                 <a:ea typeface="Calibri"/>
                 <a:cs typeface="Calibri"/>
               </a:rPr>
-              <a:t>Finish the real benchmark and camera demo; add its link, confirm the registered team name, and tag the final repository revision.</a:t>
+              <a:t>Demo: https://cursor.com/artifacts/v/art-65efdeb4-9b6f-4416-839a-875b82833f5a. Confirm the registered team name and tag the final revision.</a:t>
             </a:r>
           </a:p>
         </p:txBody>
@@ -14389,7 +14389,7 @@
                 <a:ea typeface="Calibri"/>
                 <a:cs typeface="Calibri"/>
               </a:rPr>
-              <a:t>Remaining: real demo video link, registered team-name confirmation, and final commit/tag after the rerun.</a:t>
+              <a:t>Demo: https://cursor.com/artifacts/v/art-65efdeb4-9b6f-4416-839a-875b82833f5a. Remaining: registered team-name confirmation and the final tag.</a:t>
             </a:r>
             <a:endParaRPr/>
           </a:p>

</xml_diff>

<commit_message>
Report the 70/100 run in the deck and submission docs
Slides 6-8 and the notes on every slide now give the 2026-10-04 run
(70/100 strict pass, 100/100 turn-take, 93.4%/76.3% tool and argument
accuracy, 4.452 s latency) and point to docs/results/kaggle-20261004/.
A run manifest records that run's summary and evidence hashes, and
check_submission.py verifies it and the deck numbers (it now passes).
The run review, deck notes, README and STATUS follow.

Co-Authored-By: Claude Opus 5.5 <noreply@anthropic.com>
Claude-Session: https://claude.ai/code/session_01JRy6dd119GacsGpMPLTKz1
</commit_message>
<xml_diff>
--- a/docs/Interra_Theme05_submission.pptx
+++ b/docs/Interra_Theme05_submission.pptx
@@ -481,7 +481,7 @@
               <a:buNone/>
             </a:pPr>
             <a:r>
-              <a:t>Sources: supplied Theme05_Participant_Guide_UPDATED_FBD.docx (maximum eight slides); official FDB-v3 reports and run evidence in docs/results/kaggle-20261001/; docs/ARCHITECTURE.md. Kaggle kernel version 3 completed one 100-recording run with 43 strict passes and 90 turn-takes. LiveKit logged LLM credit-quota errors; the optional organizer LLM judge and two additional repeat runs remain outstanding. Live extension demonstration is pending.</a:t>
+              <a:t>Sources: supplied Theme05_Participant_Guide_UPDATED_FBD.docx (maximum eight slides); official FDB-v3 reports and run evidence in docs/results/kaggle-20261004/; docs/ARCHITECTURE.md. The 2026-10-04 Kaggle run scored 70/100 strict passes and 100/100 turn-takes over all 100 recordings; the 29 recordings hit by a provider credit outage were re-recorded with the same code. The optional organizer LLM judge and single-session repeat runs remain outstanding. Live extension demonstration is pending.</a:t>
             </a:r>
             <a:endParaRPr/>
           </a:p>
@@ -561,7 +561,7 @@
               <a:buNone/>
             </a:pPr>
             <a:r>
-              <a:t>Sources: supplied Theme05_Participant_Guide_UPDATED_FBD.docx (maximum eight slides); official FDB-v3 reports and run evidence in docs/results/kaggle-20261001/; docs/ARCHITECTURE.md. Kaggle kernel version 3 completed one 100-recording run with 43 strict passes and 90 turn-takes. LiveKit logged LLM credit-quota errors; the optional organizer LLM judge and two additional repeat runs remain outstanding. Live extension demonstration is pending.</a:t>
+              <a:t>Sources: supplied Theme05_Participant_Guide_UPDATED_FBD.docx (maximum eight slides); official FDB-v3 reports and run evidence in docs/results/kaggle-20261004/; docs/ARCHITECTURE.md. The 2026-10-04 Kaggle run scored 70/100 strict passes and 100/100 turn-takes over all 100 recordings; the 29 recordings hit by a provider credit outage were re-recorded with the same code. The optional organizer LLM judge and single-session repeat runs remain outstanding. Live extension demonstration is pending.</a:t>
             </a:r>
             <a:endParaRPr/>
           </a:p>
@@ -641,7 +641,7 @@
               <a:buNone/>
             </a:pPr>
             <a:r>
-              <a:t>Sources: supplied Theme05_Participant_Guide_UPDATED_FBD.docx (maximum eight slides); official FDB-v3 reports and run evidence in docs/results/kaggle-20261001/; docs/ARCHITECTURE.md. Kaggle kernel version 3 completed one 100-recording run with 43 strict passes and 90 turn-takes. LiveKit logged LLM credit-quota errors; the optional organizer LLM judge and two additional repeat runs remain outstanding. Live extension demonstration is pending.</a:t>
+              <a:t>Sources: supplied Theme05_Participant_Guide_UPDATED_FBD.docx (maximum eight slides); official FDB-v3 reports and run evidence in docs/results/kaggle-20261004/; docs/ARCHITECTURE.md. The 2026-10-04 Kaggle run scored 70/100 strict passes and 100/100 turn-takes over all 100 recordings; the 29 recordings hit by a provider credit outage were re-recorded with the same code. The optional organizer LLM judge and single-session repeat runs remain outstanding. Live extension demonstration is pending.</a:t>
             </a:r>
             <a:endParaRPr/>
           </a:p>
@@ -721,7 +721,7 @@
               <a:buNone/>
             </a:pPr>
             <a:r>
-              <a:t>Sources: supplied Theme05_Participant_Guide_UPDATED_FBD.docx (maximum eight slides); official FDB-v3 reports and run evidence in docs/results/kaggle-20261001/; docs/ARCHITECTURE.md. Kaggle kernel version 3 completed one 100-recording run with 43 strict passes and 90 turn-takes. LiveKit logged LLM credit-quota errors; the optional organizer LLM judge and two additional repeat runs remain outstanding. Live extension demonstration is pending.</a:t>
+              <a:t>Sources: supplied Theme05_Participant_Guide_UPDATED_FBD.docx (maximum eight slides); official FDB-v3 reports and run evidence in docs/results/kaggle-20261004/; docs/ARCHITECTURE.md. The 2026-10-04 Kaggle run scored 70/100 strict passes and 100/100 turn-takes over all 100 recordings; the 29 recordings hit by a provider credit outage were re-recorded with the same code. The optional organizer LLM judge and single-session repeat runs remain outstanding. Live extension demonstration is pending.</a:t>
             </a:r>
             <a:endParaRPr/>
           </a:p>
@@ -801,7 +801,7 @@
               <a:buNone/>
             </a:pPr>
             <a:r>
-              <a:t>Sources: supplied Theme05_Participant_Guide_UPDATED_FBD.docx (maximum eight slides); official FDB-v3 reports and run evidence in docs/results/kaggle-20261001/; docs/ARCHITECTURE.md. Kaggle kernel version 3 completed one 100-recording run with 43 strict passes and 90 turn-takes. LiveKit logged LLM credit-quota errors; the optional organizer LLM judge and two additional repeat runs remain outstanding. Live extension demonstration is pending.</a:t>
+              <a:t>Sources: supplied Theme05_Participant_Guide_UPDATED_FBD.docx (maximum eight slides); official FDB-v3 reports and run evidence in docs/results/kaggle-20261004/; docs/ARCHITECTURE.md. The 2026-10-04 Kaggle run scored 70/100 strict passes and 100/100 turn-takes over all 100 recordings; the 29 recordings hit by a provider credit outage were re-recorded with the same code. The optional organizer LLM judge and single-session repeat runs remain outstanding. Live extension demonstration is pending.</a:t>
             </a:r>
             <a:endParaRPr/>
           </a:p>
@@ -881,7 +881,7 @@
               <a:buNone/>
             </a:pPr>
             <a:r>
-              <a:t>Sources: supplied Theme05_Participant_Guide_UPDATED_FBD.docx (maximum eight slides); official FDB-v3 reports and run evidence in docs/results/kaggle-20261001/; docs/ARCHITECTURE.md. Kaggle kernel version 3 completed one 100-recording run with 43 strict passes and 90 turn-takes. LiveKit logged LLM credit-quota errors; the optional organizer LLM judge and two additional repeat runs remain outstanding. Live extension demonstration is pending.</a:t>
+              <a:t>Sources: supplied Theme05_Participant_Guide_UPDATED_FBD.docx (maximum eight slides); official FDB-v3 reports and run evidence in docs/results/kaggle-20261004/; docs/ARCHITECTURE.md. The 2026-10-04 Kaggle run scored 70/100 strict passes and 100/100 turn-takes over all 100 recordings; the 29 recordings hit by a provider credit outage were re-recorded with the same code. The optional organizer LLM judge and single-session repeat runs remain outstanding. Live extension demonstration is pending.</a:t>
             </a:r>
             <a:endParaRPr/>
           </a:p>
@@ -961,7 +961,7 @@
               <a:buNone/>
             </a:pPr>
             <a:r>
-              <a:t>Sources: supplied Theme05_Participant_Guide_UPDATED_FBD.docx (maximum eight slides); official FDB-v3 reports and run evidence in docs/results/kaggle-20261001/; docs/ARCHITECTURE.md. Kaggle kernel version 3 completed one 100-recording run with 43 strict passes and 90 turn-takes. LiveKit logged LLM credit-quota errors; the optional organizer LLM judge and two additional repeat runs remain outstanding. Live extension demonstration is pending.</a:t>
+              <a:t>Sources: supplied Theme05_Participant_Guide_UPDATED_FBD.docx (maximum eight slides); official FDB-v3 reports and run evidence in docs/results/kaggle-20261004/; docs/ARCHITECTURE.md. The 2026-10-04 Kaggle run scored 70/100 strict passes and 100/100 turn-takes over all 100 recordings; the 29 recordings hit by a provider credit outage were re-recorded with the same code. The optional organizer LLM judge and single-session repeat runs remain outstanding. Live extension demonstration is pending.</a:t>
             </a:r>
             <a:endParaRPr/>
           </a:p>
@@ -1041,7 +1041,7 @@
               <a:buNone/>
             </a:pPr>
             <a:r>
-              <a:t>Sources: supplied Theme05_Participant_Guide_UPDATED_FBD.docx (maximum eight slides); official FDB-v3 reports and run evidence in docs/results/kaggle-20261001/; docs/ARCHITECTURE.md. Kaggle kernel version 3 completed one 100-recording run with 43 strict passes and 90 turn-takes. LiveKit logged LLM credit-quota errors; the optional organizer LLM judge and two additional repeat runs remain outstanding. Live extension demonstration is pending.</a:t>
+              <a:t>Sources: supplied Theme05_Participant_Guide_UPDATED_FBD.docx (maximum eight slides); official FDB-v3 reports and run evidence in docs/results/kaggle-20261004/; docs/ARCHITECTURE.md. The 2026-10-04 Kaggle run scored 70/100 strict passes and 100/100 turn-takes over all 100 recordings; the 29 recordings hit by a provider credit outage were re-recorded with the same code. The optional organizer LLM judge and single-session repeat runs remain outstanding. Live extension demonstration is pending.</a:t>
             </a:r>
             <a:endParaRPr/>
           </a:p>
@@ -13698,7 +13698,7 @@
                 <a:ea typeface="Calibri"/>
                 <a:cs typeface="Calibri"/>
               </a:rPr>
-              <a:t>Latest hosted run: 43/100 strict passes; 90/100 turn-takes; 10 silent recordings.</a:t>
+              <a:t>Latest hosted run: 70/100 strict passes; 100/100 turn-takes; 0 silent recordings.</a:t>
             </a:r>
           </a:p>
           <a:p xmlns:a="http://schemas.openxmlformats.org/drawingml/2006/main">
@@ -13729,7 +13729,7 @@
                 <a:ea typeface="Calibri"/>
                 <a:cs typeface="Calibri"/>
               </a:rPr>
-              <a:t>Tool selection: 85.7% on turn-taken recordings, 77.2% across all 100. Argument accuracy: 56.3% and 50.7%, respectively.</a:t>
+              <a:t>Tool selection: 93.4% and argument accuracy: 76.3% across all 100 recordings, scored by the pinned official evaluator.</a:t>
             </a:r>
           </a:p>
           <a:p xmlns:a="http://schemas.openxmlformats.org/drawingml/2006/main">
@@ -13760,7 +13760,7 @@
                 <a:ea typeface="Calibri"/>
                 <a:cs typeface="Calibri"/>
               </a:rPr>
-              <a:t>Mean response latency: 4.175 seconds, excluding 11 interruptions among 90 turn-taken recordings.</a:t>
+              <a:t>Mean response latency: 4.452 seconds, excluding 3 interruptions among 100 turn-taken recordings.</a:t>
             </a:r>
           </a:p>
           <a:p xmlns:a="http://schemas.openxmlformats.org/drawingml/2006/main">
@@ -13791,7 +13791,7 @@
                 <a:ea typeface="Calibri"/>
                 <a:cs typeface="Calibri"/>
               </a:rPr>
-              <a:t>Failures: 28 wrong tools and 29 wrong arguments. No STT HTTP 429 appears in the trace; LiveKit logged LLM credit-quota errors.</a:t>
+              <a:t>Failures: 13 wrong tools and 17 wrong arguments. 29 recordings hit by a provider credit outage were re-recorded with the same code.</a:t>
             </a:r>
           </a:p>
           <a:p xmlns:a="http://schemas.openxmlformats.org/drawingml/2006/main">
@@ -13982,7 +13982,7 @@
                 <a:ea typeface="Calibri"/>
                 <a:cs typeface="Calibri"/>
               </a:rPr>
-              <a:t>The corrected Kaggle worker completed all 100 recordings: 43 strict passes and 90 turn-takes, up from the earlier 31 and 58.</a:t>
+              <a:t>The Kaggle worker completed all 100 recordings: 70 strict passes and 100 turn-takes, up from 43 and 90, and the earlier 31 and 58.</a:t>
             </a:r>
           </a:p>
           <a:p xmlns:a="http://schemas.openxmlformats.org/drawingml/2006/main">
@@ -14013,7 +14013,7 @@
                 <a:ea typeface="Calibri"/>
                 <a:cs typeface="Calibri"/>
               </a:rPr>
-              <a:t>All 101 traced sessions were cleaned up and completed the cooldown. No STT 429 appeared; LiveKit logged exhausted LLM credits.</a:t>
+              <a:t>All 100 traced sessions were cleaned up and completed the cooldown; all 152 tool calls completed with no session errors.</a:t>
             </a:r>
           </a:p>
           <a:p xmlns:a="http://schemas.openxmlformats.org/drawingml/2006/main">
@@ -14044,7 +14044,7 @@
                 <a:ea typeface="Calibri"/>
                 <a:cs typeface="Calibri"/>
               </a:rPr>
-              <a:t>Turn-taken tool selection and argument accuracy were 85.7% and 56.3%; improve travel and identity arguments from the new traces.</a:t>
+              <a:t>Tool selection and argument accuracy were 93.4% and 76.3%; improve housing and travel arguments (69.9%, 68.3%) from the traces.</a:t>
             </a:r>
           </a:p>
           <a:p xmlns:a="http://schemas.openxmlformats.org/drawingml/2006/main">
@@ -14075,7 +14075,7 @@
                 <a:ea typeface="Calibri"/>
                 <a:cs typeface="Calibri"/>
               </a:rPr>
-              <a:t>Repeat the benchmark twice after restoring quota. Record the camera extension demo, add its link, confirm the registered team name, and tag the final revision.</a:t>
+              <a:t>Repeat the full benchmark in single sessions with enough credit. Record the camera extension demo, add its link, confirm the registered team name, and tag the final revision.</a:t>
             </a:r>
           </a:p>
         </p:txBody>
@@ -14313,7 +14313,7 @@
                 <a:ea typeface="Calibri"/>
                 <a:cs typeface="Calibri"/>
               </a:rPr>
-              <a:t>Evidence: docs/results/kaggle-20261001/ contains official reports, setup report, trace, tool-call telemetry, worker source and hashes. The aggregate reports cover 100 recordings; 15 per-recording JSONs were retrievable.</a:t>
+              <a:t>Evidence: docs/results/kaggle-20261004/ contains official reports, setup reports, traces, tool-call telemetry and logs. All 100 per-recording results are archived, with commands that reproduce 70/100.</a:t>
             </a:r>
             <a:endParaRPr sz="2800"/>
           </a:p>
@@ -14389,7 +14389,7 @@
                 <a:ea typeface="Calibri"/>
                 <a:cs typeface="Calibri"/>
               </a:rPr>
-              <a:t>Remaining: restore LiveKit LLM quota and repeat twice; record the demo; confirm registered team details.</a:t>
+              <a:t>Remaining: repeat the full benchmark in single sessions; record the demo; confirm registered team details.</a:t>
             </a:r>
             <a:endParaRPr/>
           </a:p>

</xml_diff>

<commit_message>
Report the 70/100 run in the deck and submission docs (#2)
Slides 6-8 and every slide's notes, SUBMISSION_DECK.md, KAGGLE_RUN_REVIEW.md, README and STATUS report the 2026-10-04 run. A run manifest records its summary and evidence hashes; check_submission.py verifies them and the deck numbers.

Co-Authored-By: Claude Opus 5.5 <noreply@anthropic.com>
Claude-Session: https://claude.ai/code/session_01JRy6dd119GacsGpMPLTKz1
</commit_message>
<xml_diff>
--- a/docs/Interra_Theme05_submission.pptx
+++ b/docs/Interra_Theme05_submission.pptx
@@ -481,7 +481,7 @@
               <a:buNone/>
             </a:pPr>
             <a:r>
-              <a:t>Sources: supplied Theme05_Participant_Guide_UPDATED_FBD.docx (maximum eight slides); official FDB-v3 reports and run evidence in docs/results/kaggle-20261001/; docs/ARCHITECTURE.md. Kaggle kernel version 3 completed one 100-recording run with 43 strict passes and 90 turn-takes. LiveKit logged LLM credit-quota errors; the optional organizer LLM judge and two additional repeat runs remain outstanding. Live extension demonstration is pending.</a:t>
+              <a:t>Sources: supplied Theme05_Participant_Guide_UPDATED_FBD.docx (maximum eight slides); official FDB-v3 reports and run evidence in docs/results/kaggle-20261004/; docs/ARCHITECTURE.md. The 2026-10-04 Kaggle run scored 70/100 strict passes and 100/100 turn-takes over all 100 recordings; the 29 recordings hit by a provider credit outage were re-recorded with the same code. The optional organizer LLM judge and single-session repeat runs remain outstanding. Live extension demonstration is pending.</a:t>
             </a:r>
             <a:endParaRPr/>
           </a:p>
@@ -561,7 +561,7 @@
               <a:buNone/>
             </a:pPr>
             <a:r>
-              <a:t>Sources: supplied Theme05_Participant_Guide_UPDATED_FBD.docx (maximum eight slides); official FDB-v3 reports and run evidence in docs/results/kaggle-20261001/; docs/ARCHITECTURE.md. Kaggle kernel version 3 completed one 100-recording run with 43 strict passes and 90 turn-takes. LiveKit logged LLM credit-quota errors; the optional organizer LLM judge and two additional repeat runs remain outstanding. Live extension demonstration is pending.</a:t>
+              <a:t>Sources: supplied Theme05_Participant_Guide_UPDATED_FBD.docx (maximum eight slides); official FDB-v3 reports and run evidence in docs/results/kaggle-20261004/; docs/ARCHITECTURE.md. The 2026-10-04 Kaggle run scored 70/100 strict passes and 100/100 turn-takes over all 100 recordings; the 29 recordings hit by a provider credit outage were re-recorded with the same code. The optional organizer LLM judge and single-session repeat runs remain outstanding. Live extension demonstration is pending.</a:t>
             </a:r>
             <a:endParaRPr/>
           </a:p>
@@ -641,7 +641,7 @@
               <a:buNone/>
             </a:pPr>
             <a:r>
-              <a:t>Sources: supplied Theme05_Participant_Guide_UPDATED_FBD.docx (maximum eight slides); official FDB-v3 reports and run evidence in docs/results/kaggle-20261001/; docs/ARCHITECTURE.md. Kaggle kernel version 3 completed one 100-recording run with 43 strict passes and 90 turn-takes. LiveKit logged LLM credit-quota errors; the optional organizer LLM judge and two additional repeat runs remain outstanding. Live extension demonstration is pending.</a:t>
+              <a:t>Sources: supplied Theme05_Participant_Guide_UPDATED_FBD.docx (maximum eight slides); official FDB-v3 reports and run evidence in docs/results/kaggle-20261004/; docs/ARCHITECTURE.md. The 2026-10-04 Kaggle run scored 70/100 strict passes and 100/100 turn-takes over all 100 recordings; the 29 recordings hit by a provider credit outage were re-recorded with the same code. The optional organizer LLM judge and single-session repeat runs remain outstanding. Live extension demonstration is pending.</a:t>
             </a:r>
             <a:endParaRPr/>
           </a:p>
@@ -721,7 +721,7 @@
               <a:buNone/>
             </a:pPr>
             <a:r>
-              <a:t>Sources: supplied Theme05_Participant_Guide_UPDATED_FBD.docx (maximum eight slides); official FDB-v3 reports and run evidence in docs/results/kaggle-20261001/; docs/ARCHITECTURE.md. Kaggle kernel version 3 completed one 100-recording run with 43 strict passes and 90 turn-takes. LiveKit logged LLM credit-quota errors; the optional organizer LLM judge and two additional repeat runs remain outstanding. Live extension demonstration is pending.</a:t>
+              <a:t>Sources: supplied Theme05_Participant_Guide_UPDATED_FBD.docx (maximum eight slides); official FDB-v3 reports and run evidence in docs/results/kaggle-20261004/; docs/ARCHITECTURE.md. The 2026-10-04 Kaggle run scored 70/100 strict passes and 100/100 turn-takes over all 100 recordings; the 29 recordings hit by a provider credit outage were re-recorded with the same code. The optional organizer LLM judge and single-session repeat runs remain outstanding. Live extension demonstration is pending.</a:t>
             </a:r>
             <a:endParaRPr/>
           </a:p>
@@ -801,7 +801,7 @@
               <a:buNone/>
             </a:pPr>
             <a:r>
-              <a:t>Sources: supplied Theme05_Participant_Guide_UPDATED_FBD.docx (maximum eight slides); official FDB-v3 reports and run evidence in docs/results/kaggle-20261001/; docs/ARCHITECTURE.md. Kaggle kernel version 3 completed one 100-recording run with 43 strict passes and 90 turn-takes. LiveKit logged LLM credit-quota errors; the optional organizer LLM judge and two additional repeat runs remain outstanding. Live extension demonstration is pending.</a:t>
+              <a:t>Sources: supplied Theme05_Participant_Guide_UPDATED_FBD.docx (maximum eight slides); official FDB-v3 reports and run evidence in docs/results/kaggle-20261004/; docs/ARCHITECTURE.md. The 2026-10-04 Kaggle run scored 70/100 strict passes and 100/100 turn-takes over all 100 recordings; the 29 recordings hit by a provider credit outage were re-recorded with the same code. The optional organizer LLM judge and single-session repeat runs remain outstanding. Live extension demonstration is pending.</a:t>
             </a:r>
             <a:endParaRPr/>
           </a:p>
@@ -881,7 +881,7 @@
               <a:buNone/>
             </a:pPr>
             <a:r>
-              <a:t>Sources: supplied Theme05_Participant_Guide_UPDATED_FBD.docx (maximum eight slides); official FDB-v3 reports and run evidence in docs/results/kaggle-20261001/; docs/ARCHITECTURE.md. Kaggle kernel version 3 completed one 100-recording run with 43 strict passes and 90 turn-takes. LiveKit logged LLM credit-quota errors; the optional organizer LLM judge and two additional repeat runs remain outstanding. Live extension demonstration is pending.</a:t>
+              <a:t>Sources: supplied Theme05_Participant_Guide_UPDATED_FBD.docx (maximum eight slides); official FDB-v3 reports and run evidence in docs/results/kaggle-20261004/; docs/ARCHITECTURE.md. The 2026-10-04 Kaggle run scored 70/100 strict passes and 100/100 turn-takes over all 100 recordings; the 29 recordings hit by a provider credit outage were re-recorded with the same code. The optional organizer LLM judge and single-session repeat runs remain outstanding. Live extension demonstration is pending.</a:t>
             </a:r>
             <a:endParaRPr/>
           </a:p>
@@ -961,7 +961,7 @@
               <a:buNone/>
             </a:pPr>
             <a:r>
-              <a:t>Sources: supplied Theme05_Participant_Guide_UPDATED_FBD.docx (maximum eight slides); official FDB-v3 reports and run evidence in docs/results/kaggle-20261001/; docs/ARCHITECTURE.md. Kaggle kernel version 3 completed one 100-recording run with 43 strict passes and 90 turn-takes. LiveKit logged LLM credit-quota errors; the optional organizer LLM judge and two additional repeat runs remain outstanding. Live extension demonstration is pending.</a:t>
+              <a:t>Sources: supplied Theme05_Participant_Guide_UPDATED_FBD.docx (maximum eight slides); official FDB-v3 reports and run evidence in docs/results/kaggle-20261004/; docs/ARCHITECTURE.md. The 2026-10-04 Kaggle run scored 70/100 strict passes and 100/100 turn-takes over all 100 recordings; the 29 recordings hit by a provider credit outage were re-recorded with the same code. The optional organizer LLM judge and single-session repeat runs remain outstanding. Live extension demonstration is pending.</a:t>
             </a:r>
             <a:endParaRPr/>
           </a:p>
@@ -1041,7 +1041,7 @@
               <a:buNone/>
             </a:pPr>
             <a:r>
-              <a:t>Sources: supplied Theme05_Participant_Guide_UPDATED_FBD.docx (maximum eight slides); official FDB-v3 reports and run evidence in docs/results/kaggle-20261001/; docs/ARCHITECTURE.md. Kaggle kernel version 3 completed one 100-recording run with 43 strict passes and 90 turn-takes. LiveKit logged LLM credit-quota errors; the optional organizer LLM judge and two additional repeat runs remain outstanding. Live extension demonstration is pending.</a:t>
+              <a:t>Sources: supplied Theme05_Participant_Guide_UPDATED_FBD.docx (maximum eight slides); official FDB-v3 reports and run evidence in docs/results/kaggle-20261004/; docs/ARCHITECTURE.md. The 2026-10-04 Kaggle run scored 70/100 strict passes and 100/100 turn-takes over all 100 recordings; the 29 recordings hit by a provider credit outage were re-recorded with the same code. The optional organizer LLM judge and single-session repeat runs remain outstanding. Live extension demonstration is pending.</a:t>
             </a:r>
             <a:endParaRPr/>
           </a:p>
@@ -13698,7 +13698,7 @@
                 <a:ea typeface="Calibri"/>
                 <a:cs typeface="Calibri"/>
               </a:rPr>
-              <a:t>Latest hosted run: 43/100 strict passes; 90/100 turn-takes; 10 silent recordings.</a:t>
+              <a:t>Latest hosted run: 70/100 strict passes; 100/100 turn-takes; 0 silent recordings.</a:t>
             </a:r>
           </a:p>
           <a:p xmlns:a="http://schemas.openxmlformats.org/drawingml/2006/main">
@@ -13729,7 +13729,7 @@
                 <a:ea typeface="Calibri"/>
                 <a:cs typeface="Calibri"/>
               </a:rPr>
-              <a:t>Tool selection: 85.7% on turn-taken recordings, 77.2% across all 100. Argument accuracy: 56.3% and 50.7%, respectively.</a:t>
+              <a:t>Tool selection: 93.4% and argument accuracy: 76.3% across all 100 recordings, scored by the pinned official evaluator.</a:t>
             </a:r>
           </a:p>
           <a:p xmlns:a="http://schemas.openxmlformats.org/drawingml/2006/main">
@@ -13760,7 +13760,7 @@
                 <a:ea typeface="Calibri"/>
                 <a:cs typeface="Calibri"/>
               </a:rPr>
-              <a:t>Mean response latency: 4.175 seconds, excluding 11 interruptions among 90 turn-taken recordings.</a:t>
+              <a:t>Mean response latency: 4.452 seconds, excluding 3 interruptions among 100 turn-taken recordings.</a:t>
             </a:r>
           </a:p>
           <a:p xmlns:a="http://schemas.openxmlformats.org/drawingml/2006/main">
@@ -13791,7 +13791,7 @@
                 <a:ea typeface="Calibri"/>
                 <a:cs typeface="Calibri"/>
               </a:rPr>
-              <a:t>Failures: 28 wrong tools and 29 wrong arguments. No STT HTTP 429 appears in the trace; LiveKit logged LLM credit-quota errors.</a:t>
+              <a:t>Failures: 13 wrong tools and 17 wrong arguments. 29 recordings hit by a provider credit outage were re-recorded with the same code.</a:t>
             </a:r>
           </a:p>
           <a:p xmlns:a="http://schemas.openxmlformats.org/drawingml/2006/main">
@@ -13982,7 +13982,7 @@
                 <a:ea typeface="Calibri"/>
                 <a:cs typeface="Calibri"/>
               </a:rPr>
-              <a:t>The corrected Kaggle worker completed all 100 recordings: 43 strict passes and 90 turn-takes, up from the earlier 31 and 58.</a:t>
+              <a:t>The Kaggle worker completed all 100 recordings: 70 strict passes and 100 turn-takes, up from 43 and 90, and the earlier 31 and 58.</a:t>
             </a:r>
           </a:p>
           <a:p xmlns:a="http://schemas.openxmlformats.org/drawingml/2006/main">
@@ -14013,7 +14013,7 @@
                 <a:ea typeface="Calibri"/>
                 <a:cs typeface="Calibri"/>
               </a:rPr>
-              <a:t>All 101 traced sessions were cleaned up and completed the cooldown. No STT 429 appeared; LiveKit logged exhausted LLM credits.</a:t>
+              <a:t>All 100 traced sessions were cleaned up and completed the cooldown; all 152 tool calls completed with no session errors.</a:t>
             </a:r>
           </a:p>
           <a:p xmlns:a="http://schemas.openxmlformats.org/drawingml/2006/main">
@@ -14044,7 +14044,7 @@
                 <a:ea typeface="Calibri"/>
                 <a:cs typeface="Calibri"/>
               </a:rPr>
-              <a:t>Turn-taken tool selection and argument accuracy were 85.7% and 56.3%; improve travel and identity arguments from the new traces.</a:t>
+              <a:t>Tool selection and argument accuracy were 93.4% and 76.3%; improve housing and travel arguments (69.9%, 68.3%) from the traces.</a:t>
             </a:r>
           </a:p>
           <a:p xmlns:a="http://schemas.openxmlformats.org/drawingml/2006/main">
@@ -14075,7 +14075,7 @@
                 <a:ea typeface="Calibri"/>
                 <a:cs typeface="Calibri"/>
               </a:rPr>
-              <a:t>Repeat the benchmark twice after restoring quota. Record the camera extension demo, add its link, confirm the registered team name, and tag the final revision.</a:t>
+              <a:t>Repeat the full benchmark in single sessions with enough credit. Record the camera extension demo, add its link, confirm the registered team name, and tag the final revision.</a:t>
             </a:r>
           </a:p>
         </p:txBody>
@@ -14313,7 +14313,7 @@
                 <a:ea typeface="Calibri"/>
                 <a:cs typeface="Calibri"/>
               </a:rPr>
-              <a:t>Evidence: docs/results/kaggle-20261001/ contains official reports, setup report, trace, tool-call telemetry, worker source and hashes. The aggregate reports cover 100 recordings; 15 per-recording JSONs were retrievable.</a:t>
+              <a:t>Evidence: docs/results/kaggle-20261004/ contains official reports, setup reports, traces, tool-call telemetry and logs. All 100 per-recording results are archived, with commands that reproduce 70/100.</a:t>
             </a:r>
             <a:endParaRPr sz="2800"/>
           </a:p>
@@ -14389,7 +14389,7 @@
                 <a:ea typeface="Calibri"/>
                 <a:cs typeface="Calibri"/>
               </a:rPr>
-              <a:t>Remaining: restore LiveKit LLM quota and repeat twice; record the demo; confirm registered team details.</a:t>
+              <a:t>Remaining: repeat the full benchmark in single sessions; record the demo; confirm registered team details.</a:t>
             </a:r>
             <a:endParaRPr/>
           </a:p>

</xml_diff>